<commit_message>
Update Healthcare Admission & Billing Cost Analysis presentation
</commit_message>
<xml_diff>
--- a/docs/Healthcare Admission & Billing Cost Analysis (1).pptx
+++ b/docs/Healthcare Admission & Billing Cost Analysis (1).pptx
@@ -222,7 +222,7 @@
           <a:p>
             <a:fld id="{D834B4AC-BAA1-4D53-BDB9-1822A8C5A9D9}" type="datetimeFigureOut">
               <a:rPr lang="en-US" smtClean="0"/>
-              <a:t>9/11/2026</a:t>
+              <a:t>9/12/2026</a:t>
             </a:fld>
             <a:endParaRPr lang="en-US"/>
           </a:p>
@@ -752,7 +752,7 @@
           <a:p>
             <a:fld id="{5BCAD085-E8A6-8845-BD4E-CB4CCA059FC4}" type="datetimeFigureOut">
               <a:rPr lang="en-US" smtClean="0"/>
-              <a:t>9/11/2026</a:t>
+              <a:t>9/12/2026</a:t>
             </a:fld>
             <a:endParaRPr lang="en-US"/>
           </a:p>
@@ -920,7 +920,7 @@
           <a:p>
             <a:fld id="{5BCAD085-E8A6-8845-BD4E-CB4CCA059FC4}" type="datetimeFigureOut">
               <a:rPr lang="en-US" smtClean="0"/>
-              <a:t>9/11/2026</a:t>
+              <a:t>9/12/2026</a:t>
             </a:fld>
             <a:endParaRPr lang="en-US"/>
           </a:p>
@@ -1098,7 +1098,7 @@
           <a:p>
             <a:fld id="{5BCAD085-E8A6-8845-BD4E-CB4CCA059FC4}" type="datetimeFigureOut">
               <a:rPr lang="en-US" smtClean="0"/>
-              <a:t>9/11/2026</a:t>
+              <a:t>9/12/2026</a:t>
             </a:fld>
             <a:endParaRPr lang="en-US"/>
           </a:p>
@@ -1266,7 +1266,7 @@
           <a:p>
             <a:fld id="{5BCAD085-E8A6-8845-BD4E-CB4CCA059FC4}" type="datetimeFigureOut">
               <a:rPr lang="en-US" smtClean="0"/>
-              <a:t>9/11/2026</a:t>
+              <a:t>9/12/2026</a:t>
             </a:fld>
             <a:endParaRPr lang="en-US"/>
           </a:p>
@@ -1511,7 +1511,7 @@
           <a:p>
             <a:fld id="{5BCAD085-E8A6-8845-BD4E-CB4CCA059FC4}" type="datetimeFigureOut">
               <a:rPr lang="en-US" smtClean="0"/>
-              <a:t>9/11/2026</a:t>
+              <a:t>9/12/2026</a:t>
             </a:fld>
             <a:endParaRPr lang="en-US"/>
           </a:p>
@@ -1796,7 +1796,7 @@
           <a:p>
             <a:fld id="{5BCAD085-E8A6-8845-BD4E-CB4CCA059FC4}" type="datetimeFigureOut">
               <a:rPr lang="en-US" smtClean="0"/>
-              <a:t>9/11/2026</a:t>
+              <a:t>9/12/2026</a:t>
             </a:fld>
             <a:endParaRPr lang="en-US"/>
           </a:p>
@@ -2215,7 +2215,7 @@
           <a:p>
             <a:fld id="{5BCAD085-E8A6-8845-BD4E-CB4CCA059FC4}" type="datetimeFigureOut">
               <a:rPr lang="en-US" smtClean="0"/>
-              <a:t>9/11/2026</a:t>
+              <a:t>9/12/2026</a:t>
             </a:fld>
             <a:endParaRPr lang="en-US"/>
           </a:p>
@@ -2332,7 +2332,7 @@
           <a:p>
             <a:fld id="{5BCAD085-E8A6-8845-BD4E-CB4CCA059FC4}" type="datetimeFigureOut">
               <a:rPr lang="en-US" smtClean="0"/>
-              <a:t>9/11/2026</a:t>
+              <a:t>9/12/2026</a:t>
             </a:fld>
             <a:endParaRPr lang="en-US"/>
           </a:p>
@@ -2427,7 +2427,7 @@
           <a:p>
             <a:fld id="{5BCAD085-E8A6-8845-BD4E-CB4CCA059FC4}" type="datetimeFigureOut">
               <a:rPr lang="en-US" smtClean="0"/>
-              <a:t>9/11/2026</a:t>
+              <a:t>9/12/2026</a:t>
             </a:fld>
             <a:endParaRPr lang="en-US"/>
           </a:p>
@@ -2702,7 +2702,7 @@
           <a:p>
             <a:fld id="{5BCAD085-E8A6-8845-BD4E-CB4CCA059FC4}" type="datetimeFigureOut">
               <a:rPr lang="en-US" smtClean="0"/>
-              <a:t>9/11/2026</a:t>
+              <a:t>9/12/2026</a:t>
             </a:fld>
             <a:endParaRPr lang="en-US"/>
           </a:p>
@@ -2954,7 +2954,7 @@
           <a:p>
             <a:fld id="{5BCAD085-E8A6-8845-BD4E-CB4CCA059FC4}" type="datetimeFigureOut">
               <a:rPr lang="en-US" smtClean="0"/>
-              <a:t>9/11/2026</a:t>
+              <a:t>9/12/2026</a:t>
             </a:fld>
             <a:endParaRPr lang="en-US"/>
           </a:p>
@@ -3165,7 +3165,7 @@
           <a:p>
             <a:fld id="{5BCAD085-E8A6-8845-BD4E-CB4CCA059FC4}" type="datetimeFigureOut">
               <a:rPr lang="en-US" smtClean="0"/>
-              <a:t>9/11/2026</a:t>
+              <a:t>9/12/2026</a:t>
             </a:fld>
             <a:endParaRPr lang="en-US"/>
           </a:p>
@@ -7920,8 +7920,8 @@
         </p:nvSpPr>
         <p:spPr>
           <a:xfrm>
-            <a:off x="2524125" y="3452812"/>
-            <a:ext cx="6229350" cy="190500"/>
+            <a:off x="2447059" y="3448050"/>
+            <a:ext cx="6229350" cy="196208"/>
           </a:xfrm>
           <a:prstGeom prst="rect">
             <a:avLst/>
@@ -7954,14 +7954,20 @@
               <a:t> </a:t>
             </a:r>
             <a:r>
-              <a:rPr sz="1275" b="0" i="0" u="none" dirty="0">
-                <a:solidFill>
-                  <a:srgbClr val="0284C7"/>
+              <a:rPr lang="en-US" sz="1275" b="1" i="0" u="none" dirty="0">
+                <a:solidFill>
+                  <a:srgbClr val="000000"/>
                 </a:solidFill>
                 <a:latin typeface="Inter SemiBold"/>
               </a:rPr>
-              <a:t>github.com/eshaal22/Healthcare-Admissions-Cost-Analysis</a:t>
-            </a:r>
+              <a:t>https://github.com/eshaal22/Healthcare-Admission-Billing-Cost-Analysis</a:t>
+            </a:r>
+            <a:endParaRPr sz="1275" b="1" i="0" u="none" dirty="0">
+              <a:solidFill>
+                <a:srgbClr val="0284C7"/>
+              </a:solidFill>
+              <a:latin typeface="Inter SemiBold"/>
+            </a:endParaRPr>
           </a:p>
         </p:txBody>
       </p:sp>
@@ -8013,7 +8019,7 @@
           <a:p>
             <a:pPr algn="l"/>
             <a:r>
-              <a:rPr sz="1275" b="1" i="0" u="none">
+              <a:rPr sz="1275" b="1" i="0" u="none" dirty="0">
                 <a:solidFill>
                   <a:srgbClr val="000000"/>
                 </a:solidFill>
@@ -8022,11 +8028,12 @@
               <a:t>Team LinkedIn Profiles:</a:t>
             </a:r>
             <a:r>
+              <a:rPr dirty="0"/>
               <a:t>
 </a:t>
             </a:r>
             <a:r>
-              <a:rPr sz="1275" b="0" i="0" u="none">
+              <a:rPr sz="1275" b="0" i="0" u="none" dirty="0">
                 <a:solidFill>
                   <a:srgbClr val="000000"/>
                 </a:solidFill>
@@ -8035,7 +8042,7 @@
               <a:t> Maryam Asif: </a:t>
             </a:r>
             <a:r>
-              <a:rPr sz="1275" b="0" i="0" u="none">
+              <a:rPr sz="1275" b="0" i="0" u="none" dirty="0">
                 <a:solidFill>
                   <a:srgbClr val="0284C7"/>
                 </a:solidFill>
@@ -8044,11 +8051,12 @@
               <a:t>linkedin.com/in/maryam-asif-b43164424</a:t>
             </a:r>
             <a:r>
+              <a:rPr dirty="0"/>
               <a:t>
 </a:t>
             </a:r>
             <a:r>
-              <a:rPr sz="1275" b="0" i="0" u="none">
+              <a:rPr sz="1275" b="0" i="0" u="none" dirty="0">
                 <a:solidFill>
                   <a:srgbClr val="000000"/>
                 </a:solidFill>
@@ -8057,7 +8065,7 @@
               <a:t> Eshaal Atif: </a:t>
             </a:r>
             <a:r>
-              <a:rPr sz="1275" b="0" i="0" u="none">
+              <a:rPr sz="1275" b="0" i="0" u="none" dirty="0">
                 <a:solidFill>
                   <a:srgbClr val="0284C7"/>
                 </a:solidFill>
@@ -8066,11 +8074,12 @@
               <a:t>linkedin.com/in/eshaal-atif-48a9b12b6</a:t>
             </a:r>
             <a:r>
+              <a:rPr dirty="0"/>
               <a:t>
 </a:t>
             </a:r>
             <a:r>
-              <a:rPr sz="1275" b="0" i="0" u="none">
+              <a:rPr sz="1275" b="0" i="0" u="none" dirty="0">
                 <a:solidFill>
                   <a:srgbClr val="000000"/>
                 </a:solidFill>
@@ -8079,7 +8088,7 @@
               <a:t> Dua Fatima: </a:t>
             </a:r>
             <a:r>
-              <a:rPr sz="1275" b="0" i="0" u="none">
+              <a:rPr sz="1275" b="0" i="0" u="none" dirty="0">
                 <a:solidFill>
                   <a:srgbClr val="0284C7"/>
                 </a:solidFill>
@@ -8387,7 +8396,7 @@
               </a:lnSpc>
             </a:pPr>
             <a:r>
-              <a:rPr sz="1425" b="1" i="0" u="none">
+              <a:rPr sz="1425" b="1" i="0" u="none" dirty="0">
                 <a:solidFill>
                   <a:srgbClr val="1E293B"/>
                 </a:solidFill>
@@ -8396,7 +8405,7 @@
               <a:t>Core Problem:</a:t>
             </a:r>
             <a:r>
-              <a:rPr sz="1425" b="0" i="0" u="none">
+              <a:rPr sz="1425" b="0" i="0" u="none" dirty="0">
                 <a:solidFill>
                   <a:srgbClr val="1E293B"/>
                 </a:solidFill>
@@ -8435,7 +8444,7 @@
               </a:lnSpc>
             </a:pPr>
             <a:r>
-              <a:rPr sz="1425" b="1" i="0" u="none">
+              <a:rPr sz="1425" b="1" i="0" u="none" dirty="0">
                 <a:solidFill>
                   <a:srgbClr val="1E293B"/>
                 </a:solidFill>
@@ -8444,7 +8453,7 @@
               <a:t>Operational Impact:</a:t>
             </a:r>
             <a:r>
-              <a:rPr sz="1425" b="0" i="0" u="none">
+              <a:rPr sz="1425" b="0" i="0" u="none" dirty="0">
                 <a:solidFill>
                   <a:srgbClr val="1E293B"/>
                 </a:solidFill>
@@ -8587,7 +8596,7 @@
         </p:blipFill>
         <p:spPr>
           <a:xfrm>
-            <a:off x="0" y="0"/>
+            <a:off x="119216" y="0"/>
             <a:ext cx="12192000" cy="6858000"/>
           </a:xfrm>
           <a:prstGeom prst="rect">
@@ -9193,7 +9202,7 @@
         </p:blipFill>
         <p:spPr>
           <a:xfrm>
-            <a:off x="0" y="0"/>
+            <a:off x="0" y="9832"/>
             <a:ext cx="12192000" cy="6858000"/>
           </a:xfrm>
           <a:prstGeom prst="rect">
@@ -10696,7 +10705,7 @@
         <p:spPr>
           <a:xfrm>
             <a:off x="523875" y="428625"/>
-            <a:ext cx="11668125" cy="246221"/>
+            <a:ext cx="11668125" cy="369332"/>
           </a:xfrm>
           <a:prstGeom prst="rect">
             <a:avLst/>
@@ -10711,7 +10720,7 @@
           <a:p>
             <a:pPr algn="l"/>
             <a:r>
-              <a:rPr sz="1600" b="1" i="0" u="none">
+              <a:rPr sz="2400" b="1" i="0" u="none" dirty="0">
                 <a:solidFill>
                   <a:srgbClr val="0F172A"/>
                 </a:solidFill>
@@ -10771,7 +10780,7 @@
         </p:blipFill>
         <p:spPr>
           <a:xfrm>
-            <a:off x="0" y="0"/>
+            <a:off x="0" y="19664"/>
             <a:ext cx="12192000" cy="6858000"/>
           </a:xfrm>
           <a:prstGeom prst="rect">

</xml_diff>